<commit_message>
Module 9 deck and live lab on the daily market dashboard; assignment rules
Module 9: ten slides on sentiment and FinBERT, earnings calls, DCF and
comparables, and the daily market dashboard taken apart step by step. The live
lab builds a pre-market dashboard in free Python with a refusal on missing data.
Module 10 now describes the dashboard accurately. Assignments accept any roll
number and allow one attempt per name and per roll number in each class.

Co-Authored-By: Claude Opus 5.5 <noreply@anthropic.com>
</commit_message>
<xml_diff>
--- a/slides/Module-10-GCC-Capstone.pptx
+++ b/slides/Module-10-GCC-Capstone.pptx
@@ -7895,7 +7895,7 @@
                 </a:solidFill>
                 <a:latin typeface="Georgia"/>
               </a:rPr>
-              <a:t>Numbers from the news</a:t>
+              <a:t>Claude reads the sources</a:t>
             </a:r>
           </a:p>
           <a:p>
@@ -7910,7 +7910,7 @@
                   <a:srgbClr val="1B2A41"/>
                 </a:solidFill>
               </a:rPr>
-              <a:t>Pull the figures and the key events out of each headline and report.</a:t>
+              <a:t>Claude's web search reads the news and market pages and picks out the figures.</a:t>
             </a:r>
           </a:p>
         </p:txBody>
@@ -8048,7 +8048,7 @@
                 </a:solidFill>
                 <a:latin typeface="Georgia"/>
               </a:rPr>
-              <a:t>Simple calculations</a:t>
+              <a:t>Today: done by Claude</a:t>
             </a:r>
           </a:p>
           <a:p>
@@ -8063,7 +8063,7 @@
                   <a:srgbClr val="1B2A41"/>
                 </a:solidFill>
               </a:rPr>
-              <a:t>Expected gap at the open, net institutional flow, and whether volatility is low or high.</a:t>
+              <a:t>Claude also does the arithmetic, such as the expected gap at the open. Your capstone moves this into Python.</a:t>
             </a:r>
           </a:p>
         </p:txBody>
@@ -8216,7 +8216,7 @@
                   <a:srgbClr val="1B2A41"/>
                 </a:solidFill>
               </a:rPr>
-              <a:t>The Claude API writes a short brief using only those numbers.</a:t>
+              <a:t>Claude writes a short brief from what it found.</a:t>
             </a:r>
           </a:p>
         </p:txBody>
@@ -8491,7 +8491,7 @@
                   <a:srgbClr val="C9A227"/>
                 </a:solidFill>
               </a:rPr>
-              <a:t>WHY IT IS A GOOD MODEL</a:t>
+              <a:t>THE LESSON</a:t>
             </a:r>
           </a:p>
           <a:p>
@@ -8507,7 +8507,7 @@
                 </a:solidFill>
                 <a:latin typeface="Georgia"/>
               </a:rPr>
-              <a:t>It runs without a person</a:t>
+              <a:t>Good pipeline, AI-heavy engine</a:t>
             </a:r>
           </a:p>
           <a:p>
@@ -8522,7 +8522,7 @@
                   <a:srgbClr val="C9D6EE"/>
                 </a:solidFill>
               </a:rPr>
-              <a:t>It updates itself before the market opens. Your capstone should run end to end the same way.</a:t>
+              <a:t>It runs itself every morning. But a number Claude found or worked out is hard to defend, so your engine must be Python.</a:t>
             </a:r>
           </a:p>
         </p:txBody>
@@ -9201,7 +9201,7 @@
                   <a:srgbClr val="1B2A41"/>
                 </a:solidFill>
               </a:rPr>
-              <a:t>Fetches the morning data and runs the calculations.</a:t>
+              <a:t>Sends Claude the prompt template and today's page.</a:t>
             </a:r>
           </a:p>
         </p:txBody>
@@ -9389,7 +9389,7 @@
                   <a:srgbClr val="C9D6EE"/>
                 </a:solidFill>
               </a:rPr>
-              <a:t>Writes the brief from a fixed prompt template.</a:t>
+              <a:t>Searches the web for the morning data and writes the updated page.</a:t>
             </a:r>
           </a:p>
         </p:txBody>
@@ -9562,7 +9562,7 @@
                 </a:solidFill>
                 <a:latin typeface="Georgia"/>
               </a:rPr>
-              <a:t>New page</a:t>
+              <a:t>Safety check</a:t>
             </a:r>
           </a:p>
           <a:p>
@@ -9577,7 +9577,7 @@
                   <a:srgbClr val="1B2A41"/>
                 </a:solidFill>
               </a:rPr>
-              <a:t>The script writes the updated web page.</a:t>
+              <a:t>The script checks the new page is complete before saving it.</a:t>
             </a:r>
           </a:p>
         </p:txBody>
@@ -10201,7 +10201,7 @@
                   <a:srgbClr val="FFFFFF"/>
                 </a:solidFill>
               </a:rPr>
-              <a:t>it uses the per-token API from Module 7. One short brief a day costs very little.</a:t>
+              <a:t>it uses the per-token API from Module 7, plus a small charge for each web search.</a:t>
             </a:r>
           </a:p>
         </p:txBody>

</xml_diff>